<commit_message>
Add slides for design
</commit_message>
<xml_diff>
--- a/Documentation/Thesis_Presentation_Shrestha_Ritesh.pptx
+++ b/Documentation/Thesis_Presentation_Shrestha_Ritesh.pptx
@@ -5,16 +5,18 @@
     <p:sldMasterId id="2147483648" r:id="rId1"/>
   </p:sldMasterIdLst>
   <p:notesMasterIdLst>
-    <p:notesMasterId r:id="rId6"/>
+    <p:notesMasterId r:id="rId8"/>
   </p:notesMasterIdLst>
   <p:handoutMasterIdLst>
-    <p:handoutMasterId r:id="rId7"/>
+    <p:handoutMasterId r:id="rId9"/>
   </p:handoutMasterIdLst>
   <p:sldIdLst>
     <p:sldId id="256" r:id="rId2"/>
-    <p:sldId id="258" r:id="rId3"/>
-    <p:sldId id="259" r:id="rId4"/>
-    <p:sldId id="257" r:id="rId5"/>
+    <p:sldId id="259" r:id="rId3"/>
+    <p:sldId id="257" r:id="rId4"/>
+    <p:sldId id="262" r:id="rId5"/>
+    <p:sldId id="265" r:id="rId6"/>
+    <p:sldId id="263" r:id="rId7"/>
   </p:sldIdLst>
   <p:sldSz cx="9144000" cy="5143500" type="screen16x9"/>
   <p:notesSz cx="6858000" cy="9144000"/>
@@ -304,7 +306,7 @@
               <a:pPr>
                 <a:defRPr/>
               </a:pPr>
-              <a:t>8. Januar 2023</a:t>
+              <a:t>12. Januar 2023</a:t>
             </a:fld>
             <a:endParaRPr lang="de-DE"/>
           </a:p>
@@ -926,7 +928,7 @@
               <a:pPr>
                 <a:defRPr/>
               </a:pPr>
-              <a:t>8. Januar 2023</a:t>
+              <a:t>12. Januar 2023</a:t>
             </a:fld>
             <a:endParaRPr lang="de-DE"/>
           </a:p>
@@ -2381,63 +2383,63 @@
                 <a:tabLst/>
                 <a:defRPr/>
               </a:pPr>
-              <a:t>08.01.2023</a:t>
+              <a:t>12.01.23</a:t>
             </a:fld>
             <a:r>
-              <a:rPr lang="de-DE" altLang="en-US" sz="1000" dirty="0">
+              <a:rPr lang="de-DE" altLang="en-US" sz="1000">
                 <a:cs typeface="Tahoma" panose="020B0604030504040204" pitchFamily="34" charset="0"/>
               </a:rPr>
               <a:t>  |  Institute </a:t>
             </a:r>
             <a:r>
-              <a:rPr lang="en-US" sz="1000" dirty="0" err="1">
+              <a:rPr lang="en-US" sz="1000" err="1">
                 <a:hlinkClick r:id="rId2"/>
               </a:rPr>
               <a:t>Systems@TUDa</a:t>
             </a:r>
             <a:r>
-              <a:rPr lang="en-US" sz="1000" dirty="0">
+              <a:rPr lang="en-US" sz="1000">
                 <a:hlinkClick r:id="rId2"/>
               </a:rPr>
               <a:t> Group</a:t>
             </a:r>
             <a:r>
-              <a:rPr lang="de-DE" altLang="en-US" sz="1000" dirty="0">
+              <a:rPr lang="de-DE" altLang="en-US" sz="1000">
                 <a:cs typeface="Tahoma" panose="020B0604030504040204" pitchFamily="34" charset="0"/>
               </a:rPr>
               <a:t>  |  </a:t>
             </a:r>
             <a:r>
-              <a:rPr lang="en-US" sz="1000" dirty="0"/>
+              <a:rPr lang="en-US" sz="1000"/>
               <a:t>Distributed and Networked Systems </a:t>
             </a:r>
             <a:r>
-              <a:rPr lang="de-DE" altLang="en-US" sz="1000" dirty="0">
+              <a:rPr lang="de-DE" altLang="en-US" sz="1000">
                 <a:cs typeface="Tahoma" panose="020B0604030504040204" pitchFamily="34" charset="0"/>
               </a:rPr>
               <a:t>|  Prof. </a:t>
             </a:r>
             <a:r>
-              <a:rPr lang="en-US" sz="1000" b="0" dirty="0" err="1"/>
+              <a:rPr lang="en-US" sz="1000" b="0" err="1"/>
               <a:t>Zsolt</a:t>
             </a:r>
             <a:r>
-              <a:rPr lang="en-US" sz="1000" b="0" dirty="0"/>
+              <a:rPr lang="en-US" sz="1000" b="0"/>
               <a:t> István</a:t>
             </a:r>
             <a:r>
-              <a:rPr lang="de-DE" altLang="en-US" sz="1000" dirty="0">
+              <a:rPr lang="de-DE" altLang="en-US" sz="1000">
                 <a:cs typeface="Tahoma" panose="020B0604030504040204" pitchFamily="34" charset="0"/>
               </a:rPr>
               <a:t>  |  Ritesh Shrestha</a:t>
             </a:r>
-            <a:endParaRPr lang="en-US" sz="1000" b="0" dirty="0"/>
+            <a:endParaRPr lang="en-US" sz="1000" b="0"/>
           </a:p>
           <a:p>
             <a:pPr eaLnBrk="1" hangingPunct="1">
               <a:defRPr/>
             </a:pPr>
-            <a:endParaRPr lang="de-DE" altLang="en-US" sz="1000" dirty="0">
+            <a:endParaRPr lang="de-DE" altLang="en-US" sz="1000">
               <a:cs typeface="Tahoma" panose="020B0604030504040204" pitchFamily="34" charset="0"/>
             </a:endParaRPr>
           </a:p>
@@ -2445,7 +2447,7 @@
             <a:pPr eaLnBrk="1" hangingPunct="1">
               <a:defRPr/>
             </a:pPr>
-            <a:endParaRPr lang="de-DE" altLang="en-US" sz="1000" dirty="0">
+            <a:endParaRPr lang="de-DE" altLang="en-US" sz="1000">
               <a:cs typeface="Tahoma" panose="020B0604030504040204" pitchFamily="34" charset="0"/>
             </a:endParaRPr>
           </a:p>
@@ -3772,7 +3774,7 @@
           <a:p>
             <a:pPr lvl="0"/>
             <a:r>
-              <a:rPr lang="de-DE" noProof="0" dirty="0"/>
+              <a:rPr lang="de-DE" noProof="0"/>
               <a:t>Bild durch Klicken auf Symbol hinzufügen</a:t>
             </a:r>
           </a:p>
@@ -4531,63 +4533,63 @@
                 <a:tabLst/>
                 <a:defRPr/>
               </a:pPr>
-              <a:t>08.01.2023</a:t>
+              <a:t>12.01.23</a:t>
             </a:fld>
             <a:r>
-              <a:rPr lang="de-DE" altLang="en-US" sz="1000" dirty="0">
+              <a:rPr lang="de-DE" altLang="en-US" sz="1000">
                 <a:cs typeface="Tahoma" panose="020B0604030504040204" pitchFamily="34" charset="0"/>
               </a:rPr>
               <a:t>  |  Institute </a:t>
             </a:r>
             <a:r>
-              <a:rPr lang="en-US" sz="1000" dirty="0" err="1">
+              <a:rPr lang="en-US" sz="1000" err="1">
                 <a:hlinkClick r:id="rId11"/>
               </a:rPr>
               <a:t>Systems@TUDa</a:t>
             </a:r>
             <a:r>
-              <a:rPr lang="en-US" sz="1000" dirty="0">
+              <a:rPr lang="en-US" sz="1000">
                 <a:hlinkClick r:id="rId11"/>
               </a:rPr>
               <a:t> Group</a:t>
             </a:r>
             <a:r>
-              <a:rPr lang="de-DE" altLang="en-US" sz="1000" dirty="0">
+              <a:rPr lang="de-DE" altLang="en-US" sz="1000">
                 <a:cs typeface="Tahoma" panose="020B0604030504040204" pitchFamily="34" charset="0"/>
               </a:rPr>
               <a:t>  |  </a:t>
             </a:r>
             <a:r>
-              <a:rPr lang="en-US" sz="1000" dirty="0"/>
+              <a:rPr lang="en-US" sz="1000"/>
               <a:t>Distributed and Networked Systems </a:t>
             </a:r>
             <a:r>
-              <a:rPr lang="de-DE" altLang="en-US" sz="1000" dirty="0">
+              <a:rPr lang="de-DE" altLang="en-US" sz="1000">
                 <a:cs typeface="Tahoma" panose="020B0604030504040204" pitchFamily="34" charset="0"/>
               </a:rPr>
               <a:t>|  Prof. </a:t>
             </a:r>
             <a:r>
-              <a:rPr lang="en-US" sz="1000" b="0" dirty="0" err="1"/>
+              <a:rPr lang="en-US" sz="1000" b="0" err="1"/>
               <a:t>Zsolt</a:t>
             </a:r>
             <a:r>
-              <a:rPr lang="en-US" sz="1000" b="0" dirty="0"/>
+              <a:rPr lang="en-US" sz="1000" b="0"/>
               <a:t> István</a:t>
             </a:r>
             <a:r>
-              <a:rPr lang="de-DE" altLang="en-US" sz="1000" dirty="0">
+              <a:rPr lang="de-DE" altLang="en-US" sz="1000">
                 <a:cs typeface="Tahoma" panose="020B0604030504040204" pitchFamily="34" charset="0"/>
               </a:rPr>
               <a:t>  |  Ritesh Shrestha</a:t>
             </a:r>
-            <a:endParaRPr lang="en-US" sz="1000" b="0" dirty="0"/>
+            <a:endParaRPr lang="en-US" sz="1000" b="0"/>
           </a:p>
           <a:p>
             <a:pPr eaLnBrk="1" hangingPunct="1">
               <a:defRPr/>
             </a:pPr>
-            <a:endParaRPr lang="de-DE" altLang="en-US" sz="1000" dirty="0">
+            <a:endParaRPr lang="de-DE" altLang="en-US" sz="1000">
               <a:cs typeface="Tahoma" panose="020B0604030504040204" pitchFamily="34" charset="0"/>
             </a:endParaRPr>
           </a:p>
@@ -4595,7 +4597,7 @@
             <a:pPr eaLnBrk="1" hangingPunct="1">
               <a:defRPr/>
             </a:pPr>
-            <a:endParaRPr lang="de-DE" altLang="en-US" sz="1000" dirty="0">
+            <a:endParaRPr lang="de-DE" altLang="en-US" sz="1000">
               <a:cs typeface="Tahoma" panose="020B0604030504040204" pitchFamily="34" charset="0"/>
             </a:endParaRPr>
           </a:p>
@@ -5214,7 +5216,14 @@
           <a:lstStyle/>
           <a:p>
             <a:pPr eaLnBrk="1" hangingPunct="1"/>
-            <a:endParaRPr lang="de-DE" altLang="de-DE" dirty="0"/>
+            <a:r>
+              <a:rPr lang="de-DE" altLang="de-DE" dirty="0"/>
+              <a:t>A Database Optimization </a:t>
+            </a:r>
+            <a:r>
+              <a:rPr lang="en-GB" altLang="de-DE" dirty="0"/>
+              <a:t>Strategy (Scale Out)</a:t>
+            </a:r>
           </a:p>
         </p:txBody>
       </p:sp>
@@ -5246,7 +5255,7 @@
           <a:p>
             <a:pPr eaLnBrk="1" hangingPunct="1"/>
             <a:r>
-              <a:rPr lang="de-DE" altLang="de-DE" dirty="0"/>
+              <a:rPr lang="de-DE" altLang="de-DE"/>
               <a:t>Study and Evaluation of Sharding in Distributed Databases</a:t>
             </a:r>
           </a:p>
@@ -5261,104 +5270,6 @@
 </file>
 
 <file path=ppt/slides/slide2.xml><?xml version="1.0" encoding="utf-8"?>
-<p:sld xmlns:a="http://schemas.openxmlformats.org/drawingml/2006/main" xmlns:r="http://schemas.openxmlformats.org/officeDocument/2006/relationships" xmlns:p="http://schemas.openxmlformats.org/presentationml/2006/main">
-  <p:cSld>
-    <p:spTree>
-      <p:nvGrpSpPr>
-        <p:cNvPr id="1" name=""/>
-        <p:cNvGrpSpPr/>
-        <p:nvPr/>
-      </p:nvGrpSpPr>
-      <p:grpSpPr>
-        <a:xfrm>
-          <a:off x="0" y="0"/>
-          <a:ext cx="0" cy="0"/>
-          <a:chOff x="0" y="0"/>
-          <a:chExt cx="0" cy="0"/>
-        </a:xfrm>
-      </p:grpSpPr>
-      <p:sp>
-        <p:nvSpPr>
-          <p:cNvPr id="4" name="Title 3">
-            <a:extLst>
-              <a:ext uri="{FF2B5EF4-FFF2-40B4-BE49-F238E27FC236}">
-                <a16:creationId xmlns:a16="http://schemas.microsoft.com/office/drawing/2014/main" id="{BA6D9933-9A33-43A3-F2A3-FF9243E27E07}"/>
-              </a:ext>
-            </a:extLst>
-          </p:cNvPr>
-          <p:cNvSpPr>
-            <a:spLocks noGrp="1"/>
-          </p:cNvSpPr>
-          <p:nvPr>
-            <p:ph type="title"/>
-          </p:nvPr>
-        </p:nvSpPr>
-        <p:spPr/>
-        <p:txBody>
-          <a:bodyPr/>
-          <a:lstStyle/>
-          <a:p>
-            <a:endParaRPr lang="en-US"/>
-          </a:p>
-        </p:txBody>
-      </p:sp>
-      <p:sp>
-        <p:nvSpPr>
-          <p:cNvPr id="5" name="Picture Placeholder 4">
-            <a:extLst>
-              <a:ext uri="{FF2B5EF4-FFF2-40B4-BE49-F238E27FC236}">
-                <a16:creationId xmlns:a16="http://schemas.microsoft.com/office/drawing/2014/main" id="{22BD36E1-BE11-1392-F64E-E7AF4F70E46F}"/>
-              </a:ext>
-            </a:extLst>
-          </p:cNvPr>
-          <p:cNvSpPr>
-            <a:spLocks noGrp="1"/>
-          </p:cNvSpPr>
-          <p:nvPr>
-            <p:ph type="pic" idx="1"/>
-          </p:nvPr>
-        </p:nvSpPr>
-        <p:spPr/>
-      </p:sp>
-      <p:sp>
-        <p:nvSpPr>
-          <p:cNvPr id="6" name="Text Placeholder 5">
-            <a:extLst>
-              <a:ext uri="{FF2B5EF4-FFF2-40B4-BE49-F238E27FC236}">
-                <a16:creationId xmlns:a16="http://schemas.microsoft.com/office/drawing/2014/main" id="{7967ECDC-901D-7332-D77F-24EE1AC3D62A}"/>
-              </a:ext>
-            </a:extLst>
-          </p:cNvPr>
-          <p:cNvSpPr>
-            <a:spLocks noGrp="1"/>
-          </p:cNvSpPr>
-          <p:nvPr>
-            <p:ph type="body" sz="half" idx="2"/>
-          </p:nvPr>
-        </p:nvSpPr>
-        <p:spPr/>
-        <p:txBody>
-          <a:bodyPr/>
-          <a:lstStyle/>
-          <a:p>
-            <a:endParaRPr lang="en-US"/>
-          </a:p>
-        </p:txBody>
-      </p:sp>
-    </p:spTree>
-    <p:extLst>
-      <p:ext uri="{BB962C8B-B14F-4D97-AF65-F5344CB8AC3E}">
-        <p14:creationId xmlns:p14="http://schemas.microsoft.com/office/powerpoint/2010/main" val="3781739562"/>
-      </p:ext>
-    </p:extLst>
-  </p:cSld>
-  <p:clrMapOvr>
-    <a:masterClrMapping/>
-  </p:clrMapOvr>
-</p:sld>
-</file>
-
-<file path=ppt/slides/slide3.xml><?xml version="1.0" encoding="utf-8"?>
 <p:sld xmlns:a="http://schemas.openxmlformats.org/drawingml/2006/main" xmlns:r="http://schemas.openxmlformats.org/officeDocument/2006/relationships" xmlns:p="http://schemas.openxmlformats.org/presentationml/2006/main">
   <p:cSld>
     <p:spTree>
@@ -5397,7 +5308,7 @@
           <a:lstStyle/>
           <a:p>
             <a:r>
-              <a:rPr lang="en-US" dirty="0"/>
+              <a:rPr lang="en-US"/>
               <a:t>System Design (Abstract Overview)</a:t>
             </a:r>
           </a:p>
@@ -5459,7 +5370,7 @@
               </a:spcAft>
             </a:pPr>
             <a:r>
-              <a:rPr lang="en-US" sz="1100" dirty="0">
+              <a:rPr lang="en-US" sz="1100">
                 <a:effectLst/>
                 <a:ea typeface="Calibri" panose="020F0502020204030204" pitchFamily="34" charset="0"/>
                 <a:cs typeface="Times New Roman" panose="02020603050405020304" pitchFamily="18" charset="0"/>
@@ -5480,7 +5391,7 @@
               </a:spcAft>
             </a:pPr>
             <a:r>
-              <a:rPr lang="en-US" sz="1100" dirty="0">
+              <a:rPr lang="en-US" sz="1100">
                 <a:effectLst/>
                 <a:ea typeface="Calibri" panose="020F0502020204030204" pitchFamily="34" charset="0"/>
                 <a:cs typeface="Times New Roman" panose="02020603050405020304" pitchFamily="18" charset="0"/>
@@ -5501,7 +5412,7 @@
               </a:spcAft>
             </a:pPr>
             <a:r>
-              <a:rPr lang="en-US" sz="1100" dirty="0">
+              <a:rPr lang="en-US" sz="1100">
                 <a:effectLst/>
                 <a:ea typeface="Calibri" panose="020F0502020204030204" pitchFamily="34" charset="0"/>
                 <a:cs typeface="Times New Roman" panose="02020603050405020304" pitchFamily="18" charset="0"/>
@@ -5567,14 +5478,14 @@
               </a:spcAft>
             </a:pPr>
             <a:r>
-              <a:rPr lang="en-US" sz="800" dirty="0">
+              <a:rPr lang="en-US" sz="800">
                 <a:effectLst/>
                 <a:ea typeface="Calibri" panose="020F0502020204030204" pitchFamily="34" charset="0"/>
                 <a:cs typeface="Times New Roman" panose="02020603050405020304" pitchFamily="18" charset="0"/>
               </a:rPr>
               <a:t>Sites Management</a:t>
             </a:r>
-            <a:endParaRPr lang="en-US" sz="1100" dirty="0">
+            <a:endParaRPr lang="en-US" sz="1100">
               <a:effectLst/>
               <a:ea typeface="Calibri" panose="020F0502020204030204" pitchFamily="34" charset="0"/>
               <a:cs typeface="Times New Roman" panose="02020603050405020304" pitchFamily="18" charset="0"/>
@@ -5635,7 +5546,7 @@
           <a:p>
             <a:pPr algn="ctr"/>
             <a:r>
-              <a:rPr lang="en-US" dirty="0">
+              <a:rPr lang="en-US">
                 <a:solidFill>
                   <a:schemeClr val="tx1"/>
                 </a:solidFill>
@@ -5643,7 +5554,7 @@
               <a:t>D</a:t>
             </a:r>
             <a:r>
-              <a:rPr lang="en-US" baseline="-25000" dirty="0">
+              <a:rPr lang="en-US" baseline="-25000">
                 <a:solidFill>
                   <a:schemeClr val="tx1"/>
                 </a:solidFill>
@@ -5706,7 +5617,7 @@
           <a:p>
             <a:pPr algn="ctr"/>
             <a:r>
-              <a:rPr lang="en-US" dirty="0">
+              <a:rPr lang="en-US">
                 <a:solidFill>
                   <a:schemeClr val="tx1"/>
                 </a:solidFill>
@@ -5714,7 +5625,7 @@
               <a:t>D</a:t>
             </a:r>
             <a:r>
-              <a:rPr lang="en-US" baseline="-25000" dirty="0">
+              <a:rPr lang="en-US" baseline="-25000">
                 <a:solidFill>
                   <a:schemeClr val="tx1"/>
                 </a:solidFill>
@@ -5777,7 +5688,7 @@
           <a:p>
             <a:pPr algn="ctr"/>
             <a:r>
-              <a:rPr lang="en-US" dirty="0" err="1">
+              <a:rPr lang="en-US" err="1">
                 <a:solidFill>
                   <a:schemeClr val="tx1"/>
                 </a:solidFill>
@@ -5785,14 +5696,14 @@
               <a:t>D</a:t>
             </a:r>
             <a:r>
-              <a:rPr lang="en-US" baseline="-25000" dirty="0" err="1">
+              <a:rPr lang="en-US" baseline="-25000" err="1">
                 <a:solidFill>
                   <a:schemeClr val="tx1"/>
                 </a:solidFill>
               </a:rPr>
               <a:t>n</a:t>
             </a:r>
-            <a:endParaRPr lang="en-US" baseline="-25000" dirty="0">
+            <a:endParaRPr lang="en-US" baseline="-25000">
               <a:solidFill>
                 <a:schemeClr val="tx1"/>
               </a:solidFill>
@@ -5853,7 +5764,7 @@
           <a:p>
             <a:pPr algn="ctr"/>
             <a:r>
-              <a:rPr lang="en-US" dirty="0">
+              <a:rPr lang="en-US">
                 <a:solidFill>
                   <a:schemeClr val="tx1"/>
                 </a:solidFill>
@@ -5861,7 +5772,7 @@
               <a:t>D</a:t>
             </a:r>
             <a:r>
-              <a:rPr lang="en-US" baseline="-25000" dirty="0">
+              <a:rPr lang="en-US" baseline="-25000">
                 <a:solidFill>
                   <a:schemeClr val="tx1"/>
                 </a:solidFill>
@@ -5927,13 +5838,13 @@
               </a:spcAft>
             </a:pPr>
             <a:r>
-              <a:rPr lang="en-US" sz="800" dirty="0">
+              <a:rPr lang="en-US" sz="800">
                 <a:ea typeface="Calibri" panose="020F0502020204030204" pitchFamily="34" charset="0"/>
                 <a:cs typeface="Times New Roman" panose="02020603050405020304" pitchFamily="18" charset="0"/>
               </a:rPr>
               <a:t>Query Routing</a:t>
             </a:r>
-            <a:endParaRPr lang="en-US" sz="1100" dirty="0">
+            <a:endParaRPr lang="en-US" sz="1100">
               <a:effectLst/>
               <a:ea typeface="Calibri" panose="020F0502020204030204" pitchFamily="34" charset="0"/>
               <a:cs typeface="Times New Roman" panose="02020603050405020304" pitchFamily="18" charset="0"/>
@@ -5997,14 +5908,14 @@
               </a:spcAft>
             </a:pPr>
             <a:r>
-              <a:rPr lang="en-US" sz="800" dirty="0">
+              <a:rPr lang="en-US" sz="800">
                 <a:effectLst/>
                 <a:ea typeface="Calibri" panose="020F0502020204030204" pitchFamily="34" charset="0"/>
                 <a:cs typeface="Times New Roman" panose="02020603050405020304" pitchFamily="18" charset="0"/>
               </a:rPr>
               <a:t>Result Compilation</a:t>
             </a:r>
-            <a:endParaRPr lang="en-US" sz="1100" dirty="0">
+            <a:endParaRPr lang="en-US" sz="1100">
               <a:effectLst/>
               <a:ea typeface="Calibri" panose="020F0502020204030204" pitchFamily="34" charset="0"/>
               <a:cs typeface="Times New Roman" panose="02020603050405020304" pitchFamily="18" charset="0"/>
@@ -6068,14 +5979,14 @@
               </a:spcAft>
             </a:pPr>
             <a:r>
-              <a:rPr lang="en-US" sz="800" dirty="0">
+              <a:rPr lang="en-US" sz="800">
                 <a:effectLst/>
                 <a:ea typeface="Calibri" panose="020F0502020204030204" pitchFamily="34" charset="0"/>
                 <a:cs typeface="Times New Roman" panose="02020603050405020304" pitchFamily="18" charset="0"/>
               </a:rPr>
               <a:t>Sharding Algorithm</a:t>
             </a:r>
-            <a:endParaRPr lang="en-US" sz="1100" dirty="0">
+            <a:endParaRPr lang="en-US" sz="1100">
               <a:effectLst/>
               <a:ea typeface="Calibri" panose="020F0502020204030204" pitchFamily="34" charset="0"/>
               <a:cs typeface="Times New Roman" panose="02020603050405020304" pitchFamily="18" charset="0"/>
@@ -6301,7 +6212,7 @@
           <a:lstStyle/>
           <a:p>
             <a:r>
-              <a:rPr lang="en-US" dirty="0"/>
+              <a:rPr lang="en-US"/>
               <a:t>…</a:t>
             </a:r>
           </a:p>
@@ -6336,7 +6247,7 @@
           <a:lstStyle/>
           <a:p>
             <a:r>
-              <a:rPr lang="en-US" dirty="0"/>
+              <a:rPr lang="en-US"/>
               <a:t>Clients/Applications</a:t>
             </a:r>
           </a:p>
@@ -6590,7 +6501,7 @@
           <a:lstStyle/>
           <a:p>
             <a:r>
-              <a:rPr lang="en-US" dirty="0"/>
+              <a:rPr lang="en-US"/>
               <a:t>…</a:t>
             </a:r>
           </a:p>
@@ -6625,7 +6536,7 @@
           <a:lstStyle/>
           <a:p>
             <a:r>
-              <a:rPr lang="en-US" dirty="0"/>
+              <a:rPr lang="en-US"/>
               <a:t>…</a:t>
             </a:r>
           </a:p>
@@ -6660,12 +6571,52 @@
           <a:lstStyle/>
           <a:p>
             <a:r>
-              <a:rPr lang="en-US" dirty="0"/>
+              <a:rPr lang="en-US"/>
               <a:t>Databases</a:t>
             </a:r>
           </a:p>
         </p:txBody>
       </p:sp>
+      <p:cxnSp>
+        <p:nvCxnSpPr>
+          <p:cNvPr id="4" name="Straight Connector 3">
+            <a:extLst>
+              <a:ext uri="{FF2B5EF4-FFF2-40B4-BE49-F238E27FC236}">
+                <a16:creationId xmlns:a16="http://schemas.microsoft.com/office/drawing/2014/main" id="{98320966-07F7-37FE-7E91-65320B7D89B5}"/>
+              </a:ext>
+            </a:extLst>
+          </p:cNvPr>
+          <p:cNvCxnSpPr>
+            <a:cxnSpLocks/>
+            <a:stCxn id="15" idx="3"/>
+            <a:endCxn id="16" idx="1"/>
+          </p:cNvCxnSpPr>
+          <p:nvPr/>
+        </p:nvCxnSpPr>
+        <p:spPr>
+          <a:xfrm>
+            <a:off x="5439772" y="2830448"/>
+            <a:ext cx="240171" cy="0"/>
+          </a:xfrm>
+          <a:prstGeom prst="line">
+            <a:avLst/>
+          </a:prstGeom>
+        </p:spPr>
+        <p:style>
+          <a:lnRef idx="2">
+            <a:schemeClr val="accent6"/>
+          </a:lnRef>
+          <a:fillRef idx="0">
+            <a:schemeClr val="accent6"/>
+          </a:fillRef>
+          <a:effectRef idx="1">
+            <a:schemeClr val="accent6"/>
+          </a:effectRef>
+          <a:fontRef idx="minor">
+            <a:schemeClr val="tx1"/>
+          </a:fontRef>
+        </p:style>
+      </p:cxnSp>
     </p:spTree>
     <p:extLst>
       <p:ext uri="{BB962C8B-B14F-4D97-AF65-F5344CB8AC3E}">
@@ -6679,7 +6630,7 @@
 </p:sld>
 </file>
 
-<file path=ppt/slides/slide4.xml><?xml version="1.0" encoding="utf-8"?>
+<file path=ppt/slides/slide3.xml><?xml version="1.0" encoding="utf-8"?>
 <p:sld xmlns:a="http://schemas.openxmlformats.org/drawingml/2006/main" xmlns:r="http://schemas.openxmlformats.org/officeDocument/2006/relationships" xmlns:p="http://schemas.openxmlformats.org/presentationml/2006/main">
   <p:cSld>
     <p:spTree>
@@ -6718,8 +6669,8 @@
           <a:lstStyle/>
           <a:p>
             <a:r>
-              <a:rPr lang="en-US" dirty="0"/>
-              <a:t>Middleware Architecture</a:t>
+              <a:rPr lang="en-US"/>
+              <a:t>Middleware Architecture </a:t>
             </a:r>
           </a:p>
         </p:txBody>
@@ -6739,7 +6690,7 @@
         <p:spPr>
           <a:xfrm>
             <a:off x="251520" y="1203598"/>
-            <a:ext cx="8640960" cy="3456384"/>
+            <a:ext cx="8640960" cy="1152128"/>
           </a:xfrm>
           <a:prstGeom prst="roundRect">
             <a:avLst/>
@@ -6768,10 +6719,898 @@
           </a:p>
         </p:txBody>
       </p:sp>
+      <p:sp>
+        <p:nvSpPr>
+          <p:cNvPr id="3" name="Rectangle 2">
+            <a:extLst>
+              <a:ext uri="{FF2B5EF4-FFF2-40B4-BE49-F238E27FC236}">
+                <a16:creationId xmlns:a16="http://schemas.microsoft.com/office/drawing/2014/main" id="{32E68B76-D23D-2B3E-F53B-6E8BF097826B}"/>
+              </a:ext>
+            </a:extLst>
+          </p:cNvPr>
+          <p:cNvSpPr/>
+          <p:nvPr/>
+        </p:nvSpPr>
+        <p:spPr>
+          <a:xfrm>
+            <a:off x="611560" y="1419622"/>
+            <a:ext cx="2376264" cy="720080"/>
+          </a:xfrm>
+          <a:prstGeom prst="rect">
+            <a:avLst/>
+          </a:prstGeom>
+        </p:spPr>
+        <p:style>
+          <a:lnRef idx="2">
+            <a:schemeClr val="dk1"/>
+          </a:lnRef>
+          <a:fillRef idx="1">
+            <a:schemeClr val="lt1"/>
+          </a:fillRef>
+          <a:effectRef idx="0">
+            <a:schemeClr val="dk1"/>
+          </a:effectRef>
+          <a:fontRef idx="minor">
+            <a:schemeClr val="dk1"/>
+          </a:fontRef>
+        </p:style>
+        <p:txBody>
+          <a:bodyPr rtlCol="0" anchor="ctr"/>
+          <a:lstStyle/>
+          <a:p>
+            <a:pPr algn="ctr"/>
+            <a:r>
+              <a:rPr lang="en-DE" sz="1400" dirty="0"/>
+              <a:t>Site Management</a:t>
+            </a:r>
+          </a:p>
+          <a:p>
+            <a:pPr algn="ctr"/>
+            <a:r>
+              <a:rPr lang="en-DE" sz="1400" dirty="0"/>
+              <a:t>(config.py)</a:t>
+            </a:r>
+          </a:p>
+        </p:txBody>
+      </p:sp>
+      <p:sp>
+        <p:nvSpPr>
+          <p:cNvPr id="5" name="Rectangle 4">
+            <a:extLst>
+              <a:ext uri="{FF2B5EF4-FFF2-40B4-BE49-F238E27FC236}">
+                <a16:creationId xmlns:a16="http://schemas.microsoft.com/office/drawing/2014/main" id="{77D0C61A-009A-4B5D-920A-F01E13C031BE}"/>
+              </a:ext>
+            </a:extLst>
+          </p:cNvPr>
+          <p:cNvSpPr/>
+          <p:nvPr/>
+        </p:nvSpPr>
+        <p:spPr>
+          <a:xfrm>
+            <a:off x="3383868" y="1419622"/>
+            <a:ext cx="2376264" cy="720080"/>
+          </a:xfrm>
+          <a:prstGeom prst="rect">
+            <a:avLst/>
+          </a:prstGeom>
+        </p:spPr>
+        <p:style>
+          <a:lnRef idx="2">
+            <a:schemeClr val="dk1"/>
+          </a:lnRef>
+          <a:fillRef idx="1">
+            <a:schemeClr val="lt1"/>
+          </a:fillRef>
+          <a:effectRef idx="0">
+            <a:schemeClr val="dk1"/>
+          </a:effectRef>
+          <a:fontRef idx="minor">
+            <a:schemeClr val="dk1"/>
+          </a:fontRef>
+        </p:style>
+        <p:txBody>
+          <a:bodyPr rtlCol="0" anchor="ctr"/>
+          <a:lstStyle/>
+          <a:p>
+            <a:pPr algn="ctr"/>
+            <a:r>
+              <a:rPr lang="en-DE" sz="1400" dirty="0"/>
+              <a:t>Sharding Algorithm</a:t>
+            </a:r>
+          </a:p>
+          <a:p>
+            <a:pPr algn="ctr"/>
+            <a:r>
+              <a:rPr lang="en-DE" sz="1400" dirty="0"/>
+              <a:t>(sharding.py)</a:t>
+            </a:r>
+          </a:p>
+        </p:txBody>
+      </p:sp>
+      <p:sp>
+        <p:nvSpPr>
+          <p:cNvPr id="6" name="Rectangle 5">
+            <a:extLst>
+              <a:ext uri="{FF2B5EF4-FFF2-40B4-BE49-F238E27FC236}">
+                <a16:creationId xmlns:a16="http://schemas.microsoft.com/office/drawing/2014/main" id="{A94B337C-F4F2-3C61-7FC2-14E269E4599B}"/>
+              </a:ext>
+            </a:extLst>
+          </p:cNvPr>
+          <p:cNvSpPr/>
+          <p:nvPr/>
+        </p:nvSpPr>
+        <p:spPr>
+          <a:xfrm>
+            <a:off x="6156176" y="1419622"/>
+            <a:ext cx="2376264" cy="720080"/>
+          </a:xfrm>
+          <a:prstGeom prst="rect">
+            <a:avLst/>
+          </a:prstGeom>
+        </p:spPr>
+        <p:style>
+          <a:lnRef idx="2">
+            <a:schemeClr val="dk1"/>
+          </a:lnRef>
+          <a:fillRef idx="1">
+            <a:schemeClr val="lt1"/>
+          </a:fillRef>
+          <a:effectRef idx="0">
+            <a:schemeClr val="dk1"/>
+          </a:effectRef>
+          <a:fontRef idx="minor">
+            <a:schemeClr val="dk1"/>
+          </a:fontRef>
+        </p:style>
+        <p:txBody>
+          <a:bodyPr rtlCol="0" anchor="ctr"/>
+          <a:lstStyle/>
+          <a:p>
+            <a:pPr algn="ctr"/>
+            <a:r>
+              <a:rPr lang="en-DE" sz="1400" dirty="0"/>
+              <a:t>Query Routing and Result Compilation</a:t>
+            </a:r>
+          </a:p>
+          <a:p>
+            <a:pPr algn="ctr"/>
+            <a:r>
+              <a:rPr lang="en-DE" sz="1400" dirty="0"/>
+              <a:t>(main.py)</a:t>
+            </a:r>
+          </a:p>
+        </p:txBody>
+      </p:sp>
+      <p:sp>
+        <p:nvSpPr>
+          <p:cNvPr id="7" name="Content Placeholder 2">
+            <a:extLst>
+              <a:ext uri="{FF2B5EF4-FFF2-40B4-BE49-F238E27FC236}">
+                <a16:creationId xmlns:a16="http://schemas.microsoft.com/office/drawing/2014/main" id="{6EA24665-9A18-03FB-2ED4-F67477D4CC83}"/>
+              </a:ext>
+            </a:extLst>
+          </p:cNvPr>
+          <p:cNvSpPr>
+            <a:spLocks noGrp="1"/>
+          </p:cNvSpPr>
+          <p:nvPr>
+            <p:ph idx="11"/>
+          </p:nvPr>
+        </p:nvSpPr>
+        <p:spPr>
+          <a:xfrm>
+            <a:off x="181500" y="2563962"/>
+            <a:ext cx="8782988" cy="2212826"/>
+          </a:xfrm>
+        </p:spPr>
+        <p:txBody>
+          <a:bodyPr/>
+          <a:lstStyle/>
+          <a:p>
+            <a:pPr marL="285750" indent="-285750">
+              <a:buFontTx/>
+              <a:buChar char="-"/>
+            </a:pPr>
+            <a:r>
+              <a:rPr lang="en-GB" sz="1600" dirty="0"/>
+              <a:t>Uses </a:t>
+            </a:r>
+            <a:r>
+              <a:rPr lang="en-GB" sz="1600" dirty="0" err="1"/>
+              <a:t>redis-py</a:t>
+            </a:r>
+            <a:r>
+              <a:rPr lang="en-GB" sz="1600" dirty="0"/>
+              <a:t> module as python interface to the </a:t>
+            </a:r>
+            <a:r>
+              <a:rPr lang="en-GB" sz="1600" dirty="0" err="1"/>
+              <a:t>redis</a:t>
+            </a:r>
+            <a:r>
+              <a:rPr lang="en-GB" sz="1600" dirty="0"/>
+              <a:t> key-value store (databases)</a:t>
+            </a:r>
+          </a:p>
+          <a:p>
+            <a:pPr marL="285750" indent="-285750">
+              <a:buFontTx/>
+              <a:buChar char="-"/>
+            </a:pPr>
+            <a:r>
+              <a:rPr lang="en-GB" sz="1600" dirty="0"/>
+              <a:t>Acts as a client to all running </a:t>
+            </a:r>
+            <a:r>
+              <a:rPr lang="en-GB" sz="1600" dirty="0" err="1"/>
+              <a:t>redis</a:t>
+            </a:r>
+            <a:r>
+              <a:rPr lang="en-GB" sz="1600" dirty="0"/>
+              <a:t> database instances</a:t>
+            </a:r>
+          </a:p>
+          <a:p>
+            <a:pPr marL="285750" indent="-285750">
+              <a:buFontTx/>
+              <a:buChar char="-"/>
+            </a:pPr>
+            <a:r>
+              <a:rPr lang="en-GB" sz="1600" dirty="0"/>
+              <a:t>Acts as a server to all applications using the middleware</a:t>
+            </a:r>
+          </a:p>
+          <a:p>
+            <a:pPr marL="285750" indent="-285750">
+              <a:buFontTx/>
+              <a:buChar char="-"/>
+            </a:pPr>
+            <a:r>
+              <a:rPr lang="en-GB" sz="1600" dirty="0"/>
+              <a:t>Serves as an interface between applications and </a:t>
+            </a:r>
+            <a:r>
+              <a:rPr lang="en-GB" sz="1600" dirty="0" err="1"/>
+              <a:t>redis</a:t>
+            </a:r>
+            <a:r>
+              <a:rPr lang="en-GB" sz="1600" dirty="0"/>
+              <a:t> database instances</a:t>
+            </a:r>
+          </a:p>
+          <a:p>
+            <a:pPr marL="358775" lvl="2" indent="0">
+              <a:buNone/>
+            </a:pPr>
+            <a:endParaRPr lang="en-GB" sz="1600" dirty="0"/>
+          </a:p>
+          <a:p>
+            <a:pPr marL="701675" lvl="2" indent="-342900"/>
+            <a:endParaRPr lang="en-GB" sz="1600" dirty="0"/>
+          </a:p>
+          <a:p>
+            <a:pPr marL="538162" lvl="3" indent="0">
+              <a:buNone/>
+            </a:pPr>
+            <a:endParaRPr lang="en-DE" dirty="0"/>
+          </a:p>
+        </p:txBody>
+      </p:sp>
     </p:spTree>
     <p:extLst>
       <p:ext uri="{BB962C8B-B14F-4D97-AF65-F5344CB8AC3E}">
         <p14:creationId xmlns:p14="http://schemas.microsoft.com/office/powerpoint/2010/main" val="2764348885"/>
+      </p:ext>
+    </p:extLst>
+  </p:cSld>
+  <p:clrMapOvr>
+    <a:masterClrMapping/>
+  </p:clrMapOvr>
+</p:sld>
+</file>
+
+<file path=ppt/slides/slide4.xml><?xml version="1.0" encoding="utf-8"?>
+<p:sld xmlns:a="http://schemas.openxmlformats.org/drawingml/2006/main" xmlns:r="http://schemas.openxmlformats.org/officeDocument/2006/relationships" xmlns:p="http://schemas.openxmlformats.org/presentationml/2006/main">
+  <p:cSld>
+    <p:spTree>
+      <p:nvGrpSpPr>
+        <p:cNvPr id="1" name=""/>
+        <p:cNvGrpSpPr/>
+        <p:nvPr/>
+      </p:nvGrpSpPr>
+      <p:grpSpPr>
+        <a:xfrm>
+          <a:off x="0" y="0"/>
+          <a:ext cx="0" cy="0"/>
+          <a:chOff x="0" y="0"/>
+          <a:chExt cx="0" cy="0"/>
+        </a:xfrm>
+      </p:grpSpPr>
+      <p:sp>
+        <p:nvSpPr>
+          <p:cNvPr id="2" name="Title 1">
+            <a:extLst>
+              <a:ext uri="{FF2B5EF4-FFF2-40B4-BE49-F238E27FC236}">
+                <a16:creationId xmlns:a16="http://schemas.microsoft.com/office/drawing/2014/main" id="{EDC9B7EB-0030-1A9A-32B1-9AF680C75FB6}"/>
+              </a:ext>
+            </a:extLst>
+          </p:cNvPr>
+          <p:cNvSpPr>
+            <a:spLocks noGrp="1"/>
+          </p:cNvSpPr>
+          <p:nvPr>
+            <p:ph type="title"/>
+          </p:nvPr>
+        </p:nvSpPr>
+        <p:spPr/>
+        <p:txBody>
+          <a:bodyPr/>
+          <a:lstStyle/>
+          <a:p>
+            <a:r>
+              <a:rPr lang="en-DE"/>
+              <a:t>Middleware Components (Python Implementation)</a:t>
+            </a:r>
+          </a:p>
+        </p:txBody>
+      </p:sp>
+      <p:sp>
+        <p:nvSpPr>
+          <p:cNvPr id="3" name="Content Placeholder 2">
+            <a:extLst>
+              <a:ext uri="{FF2B5EF4-FFF2-40B4-BE49-F238E27FC236}">
+                <a16:creationId xmlns:a16="http://schemas.microsoft.com/office/drawing/2014/main" id="{F62F2485-30E6-C8F4-1001-4D84BAC054CD}"/>
+              </a:ext>
+            </a:extLst>
+          </p:cNvPr>
+          <p:cNvSpPr>
+            <a:spLocks noGrp="1"/>
+          </p:cNvSpPr>
+          <p:nvPr>
+            <p:ph idx="11"/>
+          </p:nvPr>
+        </p:nvSpPr>
+        <p:spPr/>
+        <p:txBody>
+          <a:bodyPr/>
+          <a:lstStyle/>
+          <a:p>
+            <a:pPr marL="0" indent="0"/>
+            <a:r>
+              <a:rPr lang="en-DE" dirty="0"/>
+              <a:t>1.  Sites Management (config.py)</a:t>
+            </a:r>
+          </a:p>
+          <a:p>
+            <a:pPr marL="701675" lvl="2" indent="-342900">
+              <a:buFont typeface="Wingdings" pitchFamily="2" charset="2"/>
+              <a:buChar char="Ø"/>
+            </a:pPr>
+            <a:r>
+              <a:rPr lang="en-GB" i="1" dirty="0" err="1"/>
+              <a:t>InfoTable</a:t>
+            </a:r>
+            <a:r>
+              <a:rPr lang="en-GB" dirty="0"/>
+              <a:t> class: </a:t>
+            </a:r>
+          </a:p>
+          <a:p>
+            <a:pPr marL="881062" lvl="3" indent="-342900"/>
+            <a:r>
+              <a:rPr lang="en-GB" b="1" i="1" dirty="0"/>
+              <a:t>info</a:t>
+            </a:r>
+            <a:r>
+              <a:rPr lang="en-DE" dirty="0"/>
+              <a:t> – Lookup table (python dictionary) with hash-key to site mappings (Key: hash-key, Value: site (URL to redis database server)</a:t>
+            </a:r>
+          </a:p>
+          <a:p>
+            <a:pPr marL="881062" lvl="3" indent="-342900"/>
+            <a:r>
+              <a:rPr lang="en-GB" b="1" dirty="0"/>
+              <a:t>g</a:t>
+            </a:r>
+            <a:r>
+              <a:rPr lang="en-DE" b="1" dirty="0"/>
+              <a:t>et_site </a:t>
+            </a:r>
+            <a:r>
+              <a:rPr lang="en-DE" dirty="0"/>
+              <a:t>function – Get site URL from the given hash key</a:t>
+            </a:r>
+          </a:p>
+          <a:p>
+            <a:pPr marL="881062" lvl="3" indent="-342900"/>
+            <a:r>
+              <a:rPr lang="en-GB" b="1" dirty="0"/>
+              <a:t>s</a:t>
+            </a:r>
+            <a:r>
+              <a:rPr lang="en-DE" b="1" dirty="0"/>
+              <a:t>et_site </a:t>
+            </a:r>
+            <a:r>
+              <a:rPr lang="en-DE" dirty="0"/>
+              <a:t>function – Sets site as value from given hash key via sharding algorithm</a:t>
+            </a:r>
+            <a:br>
+              <a:rPr lang="en-DE" dirty="0"/>
+            </a:br>
+            <a:endParaRPr lang="en-GB" dirty="0"/>
+          </a:p>
+          <a:p>
+            <a:pPr marL="701675" lvl="2" indent="-342900">
+              <a:buFont typeface="Wingdings" pitchFamily="2" charset="2"/>
+              <a:buChar char="Ø"/>
+            </a:pPr>
+            <a:r>
+              <a:rPr lang="en-GB" i="1" dirty="0" err="1"/>
+              <a:t>Xxhash</a:t>
+            </a:r>
+            <a:r>
+              <a:rPr lang="en-GB" dirty="0"/>
+              <a:t> function:</a:t>
+            </a:r>
+          </a:p>
+          <a:p>
+            <a:pPr marL="881062" lvl="3" indent="-342900"/>
+            <a:r>
+              <a:rPr lang="en-GB" b="1" dirty="0" err="1"/>
+              <a:t>hash_func</a:t>
+            </a:r>
+            <a:r>
+              <a:rPr lang="en-GB" b="1" dirty="0"/>
+              <a:t> </a:t>
+            </a:r>
+            <a:r>
+              <a:rPr lang="en-GB" dirty="0"/>
+              <a:t>– Generates 64-bit hashes, using vectorized arithmetic.</a:t>
+            </a:r>
+          </a:p>
+          <a:p>
+            <a:pPr marL="701675" lvl="2" indent="-342900"/>
+            <a:endParaRPr lang="en-GB" dirty="0"/>
+          </a:p>
+          <a:p>
+            <a:pPr marL="538162" lvl="3" indent="0">
+              <a:buNone/>
+            </a:pPr>
+            <a:endParaRPr lang="en-DE" dirty="0"/>
+          </a:p>
+        </p:txBody>
+      </p:sp>
+    </p:spTree>
+    <p:extLst>
+      <p:ext uri="{BB962C8B-B14F-4D97-AF65-F5344CB8AC3E}">
+        <p14:creationId xmlns:p14="http://schemas.microsoft.com/office/powerpoint/2010/main" val="1555184552"/>
+      </p:ext>
+    </p:extLst>
+  </p:cSld>
+  <p:clrMapOvr>
+    <a:masterClrMapping/>
+  </p:clrMapOvr>
+</p:sld>
+</file>
+
+<file path=ppt/slides/slide5.xml><?xml version="1.0" encoding="utf-8"?>
+<p:sld xmlns:a="http://schemas.openxmlformats.org/drawingml/2006/main" xmlns:r="http://schemas.openxmlformats.org/officeDocument/2006/relationships" xmlns:p="http://schemas.openxmlformats.org/presentationml/2006/main">
+  <p:cSld>
+    <p:spTree>
+      <p:nvGrpSpPr>
+        <p:cNvPr id="1" name=""/>
+        <p:cNvGrpSpPr/>
+        <p:nvPr/>
+      </p:nvGrpSpPr>
+      <p:grpSpPr>
+        <a:xfrm>
+          <a:off x="0" y="0"/>
+          <a:ext cx="0" cy="0"/>
+          <a:chOff x="0" y="0"/>
+          <a:chExt cx="0" cy="0"/>
+        </a:xfrm>
+      </p:grpSpPr>
+      <p:sp>
+        <p:nvSpPr>
+          <p:cNvPr id="2" name="Title 1">
+            <a:extLst>
+              <a:ext uri="{FF2B5EF4-FFF2-40B4-BE49-F238E27FC236}">
+                <a16:creationId xmlns:a16="http://schemas.microsoft.com/office/drawing/2014/main" id="{EDC9B7EB-0030-1A9A-32B1-9AF680C75FB6}"/>
+              </a:ext>
+            </a:extLst>
+          </p:cNvPr>
+          <p:cNvSpPr>
+            <a:spLocks noGrp="1"/>
+          </p:cNvSpPr>
+          <p:nvPr>
+            <p:ph type="title"/>
+          </p:nvPr>
+        </p:nvSpPr>
+        <p:spPr/>
+        <p:txBody>
+          <a:bodyPr/>
+          <a:lstStyle/>
+          <a:p>
+            <a:r>
+              <a:rPr lang="en-DE"/>
+              <a:t>Middleware Components (Python Implementation)</a:t>
+            </a:r>
+          </a:p>
+        </p:txBody>
+      </p:sp>
+      <p:sp>
+        <p:nvSpPr>
+          <p:cNvPr id="3" name="Content Placeholder 2">
+            <a:extLst>
+              <a:ext uri="{FF2B5EF4-FFF2-40B4-BE49-F238E27FC236}">
+                <a16:creationId xmlns:a16="http://schemas.microsoft.com/office/drawing/2014/main" id="{F62F2485-30E6-C8F4-1001-4D84BAC054CD}"/>
+              </a:ext>
+            </a:extLst>
+          </p:cNvPr>
+          <p:cNvSpPr>
+            <a:spLocks noGrp="1"/>
+          </p:cNvSpPr>
+          <p:nvPr>
+            <p:ph idx="11"/>
+          </p:nvPr>
+        </p:nvSpPr>
+        <p:spPr>
+          <a:xfrm>
+            <a:off x="180490" y="1185474"/>
+            <a:ext cx="8783998" cy="3591314"/>
+          </a:xfrm>
+        </p:spPr>
+        <p:txBody>
+          <a:bodyPr/>
+          <a:lstStyle/>
+          <a:p>
+            <a:pPr marL="0" indent="0"/>
+            <a:r>
+              <a:rPr lang="en-DE" dirty="0"/>
+              <a:t>2.  Sharding Algorithm (sharding.py)</a:t>
+            </a:r>
+          </a:p>
+          <a:p>
+            <a:pPr marL="701675" lvl="2" indent="-342900">
+              <a:buFont typeface="Wingdings" pitchFamily="2" charset="2"/>
+              <a:buChar char="Ø"/>
+            </a:pPr>
+            <a:r>
+              <a:rPr lang="en-GB" i="1" dirty="0"/>
+              <a:t>Jump Consistent Hash </a:t>
+            </a:r>
+            <a:r>
+              <a:rPr lang="en-GB" i="1"/>
+              <a:t>Algorithm</a:t>
+            </a:r>
+            <a:r>
+              <a:rPr lang="en-GB" sz="1600" i="1"/>
+              <a:t>:</a:t>
+            </a:r>
+            <a:endParaRPr lang="en-GB" sz="1400" i="1" dirty="0"/>
+          </a:p>
+          <a:p>
+            <a:pPr marL="881062" lvl="3" indent="-342900">
+              <a:buFont typeface="Wingdings" pitchFamily="2" charset="2"/>
+              <a:buChar char="Ø"/>
+            </a:pPr>
+            <a:r>
+              <a:rPr lang="en-GB" sz="1400" i="1" dirty="0"/>
+              <a:t>Attached reference: https://</a:t>
+            </a:r>
+            <a:r>
+              <a:rPr lang="en-GB" sz="1400" i="1" dirty="0" err="1"/>
+              <a:t>arxiv.org</a:t>
+            </a:r>
+            <a:r>
+              <a:rPr lang="en-GB" sz="1400" i="1" dirty="0"/>
+              <a:t>/abs/1406.2294</a:t>
+            </a:r>
+            <a:endParaRPr lang="en-GB" dirty="0"/>
+          </a:p>
+          <a:p>
+            <a:pPr marL="1014412" lvl="4" indent="-285750">
+              <a:buFontTx/>
+              <a:buChar char="-"/>
+            </a:pPr>
+            <a:endParaRPr lang="en-GB" dirty="0"/>
+          </a:p>
+          <a:p>
+            <a:pPr marL="358775" lvl="2" indent="0">
+              <a:buNone/>
+            </a:pPr>
+            <a:endParaRPr lang="en-GB" dirty="0"/>
+          </a:p>
+          <a:p>
+            <a:pPr marL="701675" lvl="2" indent="-342900"/>
+            <a:endParaRPr lang="en-GB" dirty="0"/>
+          </a:p>
+          <a:p>
+            <a:pPr marL="538162" lvl="3" indent="0">
+              <a:buNone/>
+            </a:pPr>
+            <a:endParaRPr lang="en-DE" dirty="0"/>
+          </a:p>
+        </p:txBody>
+      </p:sp>
+    </p:spTree>
+    <p:extLst>
+      <p:ext uri="{BB962C8B-B14F-4D97-AF65-F5344CB8AC3E}">
+        <p14:creationId xmlns:p14="http://schemas.microsoft.com/office/powerpoint/2010/main" val="3247730159"/>
+      </p:ext>
+    </p:extLst>
+  </p:cSld>
+  <p:clrMapOvr>
+    <a:masterClrMapping/>
+  </p:clrMapOvr>
+</p:sld>
+</file>
+
+<file path=ppt/slides/slide6.xml><?xml version="1.0" encoding="utf-8"?>
+<p:sld xmlns:a="http://schemas.openxmlformats.org/drawingml/2006/main" xmlns:r="http://schemas.openxmlformats.org/officeDocument/2006/relationships" xmlns:p="http://schemas.openxmlformats.org/presentationml/2006/main">
+  <p:cSld>
+    <p:spTree>
+      <p:nvGrpSpPr>
+        <p:cNvPr id="1" name=""/>
+        <p:cNvGrpSpPr/>
+        <p:nvPr/>
+      </p:nvGrpSpPr>
+      <p:grpSpPr>
+        <a:xfrm>
+          <a:off x="0" y="0"/>
+          <a:ext cx="0" cy="0"/>
+          <a:chOff x="0" y="0"/>
+          <a:chExt cx="0" cy="0"/>
+        </a:xfrm>
+      </p:grpSpPr>
+      <p:sp>
+        <p:nvSpPr>
+          <p:cNvPr id="2" name="Title 1">
+            <a:extLst>
+              <a:ext uri="{FF2B5EF4-FFF2-40B4-BE49-F238E27FC236}">
+                <a16:creationId xmlns:a16="http://schemas.microsoft.com/office/drawing/2014/main" id="{EDC9B7EB-0030-1A9A-32B1-9AF680C75FB6}"/>
+              </a:ext>
+            </a:extLst>
+          </p:cNvPr>
+          <p:cNvSpPr>
+            <a:spLocks noGrp="1"/>
+          </p:cNvSpPr>
+          <p:nvPr>
+            <p:ph type="title"/>
+          </p:nvPr>
+        </p:nvSpPr>
+        <p:spPr/>
+        <p:txBody>
+          <a:bodyPr/>
+          <a:lstStyle/>
+          <a:p>
+            <a:r>
+              <a:rPr lang="en-DE"/>
+              <a:t>Middleware Components (Python Implementation)</a:t>
+            </a:r>
+          </a:p>
+        </p:txBody>
+      </p:sp>
+      <p:sp>
+        <p:nvSpPr>
+          <p:cNvPr id="3" name="Content Placeholder 2">
+            <a:extLst>
+              <a:ext uri="{FF2B5EF4-FFF2-40B4-BE49-F238E27FC236}">
+                <a16:creationId xmlns:a16="http://schemas.microsoft.com/office/drawing/2014/main" id="{F62F2485-30E6-C8F4-1001-4D84BAC054CD}"/>
+              </a:ext>
+            </a:extLst>
+          </p:cNvPr>
+          <p:cNvSpPr>
+            <a:spLocks noGrp="1"/>
+          </p:cNvSpPr>
+          <p:nvPr>
+            <p:ph idx="11"/>
+          </p:nvPr>
+        </p:nvSpPr>
+        <p:spPr>
+          <a:xfrm>
+            <a:off x="180490" y="1185474"/>
+            <a:ext cx="8783998" cy="3591314"/>
+          </a:xfrm>
+        </p:spPr>
+        <p:txBody>
+          <a:bodyPr/>
+          <a:lstStyle/>
+          <a:p>
+            <a:pPr marL="0" indent="0"/>
+            <a:r>
+              <a:rPr lang="en-DE" dirty="0"/>
+              <a:t>3.  Query Routing and Result Compilation (main.py)</a:t>
+            </a:r>
+          </a:p>
+          <a:p>
+            <a:pPr marL="701675" lvl="2" indent="-342900">
+              <a:buFont typeface="Wingdings" pitchFamily="2" charset="2"/>
+              <a:buChar char="Ø"/>
+            </a:pPr>
+            <a:r>
+              <a:rPr lang="en-GB" i="1" dirty="0" err="1"/>
+              <a:t>MWare</a:t>
+            </a:r>
+            <a:r>
+              <a:rPr lang="en-GB" dirty="0"/>
+              <a:t> class: </a:t>
+            </a:r>
+          </a:p>
+          <a:p>
+            <a:pPr marL="881062" lvl="3" indent="-342900"/>
+            <a:r>
+              <a:rPr lang="en-GB" dirty="0"/>
+              <a:t>Key-Value Store:</a:t>
+            </a:r>
+          </a:p>
+          <a:p>
+            <a:pPr marL="1014412" lvl="4" indent="-285750">
+              <a:buFontTx/>
+              <a:buChar char="-"/>
+            </a:pPr>
+            <a:r>
+              <a:rPr lang="en-GB" sz="1400" b="1" dirty="0"/>
+              <a:t>Key</a:t>
+            </a:r>
+            <a:r>
+              <a:rPr lang="en-GB" sz="1400" dirty="0"/>
+              <a:t>: Client:&lt;Client-id&gt;:&lt;Unique-identifier&gt;</a:t>
+            </a:r>
+          </a:p>
+          <a:p>
+            <a:pPr marL="1014412" lvl="4" indent="-285750">
+              <a:buFontTx/>
+              <a:buChar char="-"/>
+            </a:pPr>
+            <a:r>
+              <a:rPr lang="en-GB" sz="1400" b="1" dirty="0"/>
+              <a:t>Value</a:t>
+            </a:r>
+            <a:r>
+              <a:rPr lang="en-GB" sz="1400" dirty="0"/>
+              <a:t>: </a:t>
+            </a:r>
+            <a:r>
+              <a:rPr lang="en-GB" sz="1400" dirty="0" err="1"/>
+              <a:t>Key:Value</a:t>
+            </a:r>
+            <a:r>
+              <a:rPr lang="en-GB" sz="1400" dirty="0"/>
+              <a:t> mapping (python dictionary data type)</a:t>
+            </a:r>
+          </a:p>
+          <a:p>
+            <a:pPr marL="881062" lvl="3" indent="-342900"/>
+            <a:r>
+              <a:rPr lang="en-GB" dirty="0"/>
+              <a:t>Functions:</a:t>
+            </a:r>
+          </a:p>
+          <a:p>
+            <a:pPr marL="1014412" lvl="4" indent="-285750">
+              <a:buFontTx/>
+              <a:buChar char="-"/>
+            </a:pPr>
+            <a:r>
+              <a:rPr lang="en-GB" sz="1400" b="1" dirty="0"/>
+              <a:t>Set, Get </a:t>
+            </a:r>
+            <a:r>
+              <a:rPr lang="en-GB" sz="1400" dirty="0"/>
+              <a:t>and </a:t>
+            </a:r>
+            <a:r>
+              <a:rPr lang="en-GB" sz="1400" b="1" dirty="0"/>
+              <a:t>Delete</a:t>
+            </a:r>
+            <a:r>
+              <a:rPr lang="en-GB" sz="1400" dirty="0"/>
+              <a:t> </a:t>
+            </a:r>
+            <a:r>
+              <a:rPr lang="en-GB" sz="1400" b="1" dirty="0"/>
+              <a:t>values</a:t>
+            </a:r>
+            <a:r>
+              <a:rPr lang="en-GB" sz="1400" dirty="0"/>
+              <a:t> with single and multiple keys</a:t>
+            </a:r>
+          </a:p>
+          <a:p>
+            <a:pPr marL="1014412" lvl="4" indent="-285750">
+              <a:buFontTx/>
+              <a:buChar char="-"/>
+            </a:pPr>
+            <a:r>
+              <a:rPr lang="en-GB" sz="1400" b="1" dirty="0"/>
+              <a:t>Get </a:t>
+            </a:r>
+            <a:r>
+              <a:rPr lang="en-GB" sz="1400" dirty="0"/>
+              <a:t>and </a:t>
+            </a:r>
+            <a:r>
+              <a:rPr lang="en-GB" sz="1400" b="1" dirty="0"/>
+              <a:t>Delete fields </a:t>
+            </a:r>
+            <a:r>
+              <a:rPr lang="en-GB" sz="1400" dirty="0"/>
+              <a:t>of the value with single key</a:t>
+            </a:r>
+          </a:p>
+          <a:p>
+            <a:pPr marL="1014412" lvl="4" indent="-285750">
+              <a:buFontTx/>
+              <a:buChar char="-"/>
+            </a:pPr>
+            <a:r>
+              <a:rPr lang="en-GB" sz="1400" b="1" dirty="0"/>
+              <a:t>Flush</a:t>
+            </a:r>
+            <a:r>
+              <a:rPr lang="en-GB" sz="1400" dirty="0"/>
+              <a:t> all database instances</a:t>
+            </a:r>
+          </a:p>
+          <a:p>
+            <a:pPr marL="1014412" lvl="4" indent="-285750">
+              <a:buFontTx/>
+              <a:buChar char="-"/>
+            </a:pPr>
+            <a:r>
+              <a:rPr lang="en-GB" sz="1400" b="1" dirty="0"/>
+              <a:t>Key-space (total keys) information </a:t>
+            </a:r>
+            <a:r>
+              <a:rPr lang="en-GB" sz="1400" dirty="0"/>
+              <a:t>for all given sites</a:t>
+            </a:r>
+          </a:p>
+          <a:p>
+            <a:pPr marL="1014412" lvl="4" indent="-285750">
+              <a:buFontTx/>
+              <a:buChar char="-"/>
+            </a:pPr>
+            <a:endParaRPr lang="en-GB" sz="1400" dirty="0"/>
+          </a:p>
+          <a:p>
+            <a:pPr marL="1014412" lvl="4" indent="-285750">
+              <a:buFontTx/>
+              <a:buChar char="-"/>
+            </a:pPr>
+            <a:endParaRPr lang="en-GB" dirty="0"/>
+          </a:p>
+          <a:p>
+            <a:pPr marL="1014412" lvl="4" indent="-285750">
+              <a:buFontTx/>
+              <a:buChar char="-"/>
+            </a:pPr>
+            <a:endParaRPr lang="en-GB" dirty="0"/>
+          </a:p>
+          <a:p>
+            <a:pPr marL="358775" lvl="2" indent="0">
+              <a:buNone/>
+            </a:pPr>
+            <a:endParaRPr lang="en-GB" dirty="0"/>
+          </a:p>
+          <a:p>
+            <a:pPr marL="701675" lvl="2" indent="-342900"/>
+            <a:endParaRPr lang="en-GB" dirty="0"/>
+          </a:p>
+          <a:p>
+            <a:pPr marL="538162" lvl="3" indent="0">
+              <a:buNone/>
+            </a:pPr>
+            <a:endParaRPr lang="en-DE" dirty="0"/>
+          </a:p>
+        </p:txBody>
+      </p:sp>
+    </p:spTree>
+    <p:extLst>
+      <p:ext uri="{BB962C8B-B14F-4D97-AF65-F5344CB8AC3E}">
+        <p14:creationId xmlns:p14="http://schemas.microsoft.com/office/powerpoint/2010/main" val="270155359"/>
       </p:ext>
     </p:extLst>
   </p:cSld>

</xml_diff>